<commit_message>
mark inclass-test-1 and dev weeks 5 -> 9
</commit_message>
<xml_diff>
--- a/topic05-list-comprehensions/unit-05a-lectures/talk-1/a-list-comprehensions.pptx
+++ b/topic05-list-comprehensions/unit-05a-lectures/talk-1/a-list-comprehensions.pptx
@@ -556,14 +556,14 @@
           </a:ln>
           <a:extLst>
             <a:ext uri="{909E8E84-426E-40dd-AFC4-6F175D3DCCD1}">
-              <a14:hiddenFill xmlns:a14="http://schemas.microsoft.com/office/drawing/2010/main" xmlns="">
+              <a14:hiddenFill xmlns="" xmlns:a14="http://schemas.microsoft.com/office/drawing/2010/main">
                 <a:solidFill>
                   <a:srgbClr val="FFFFFF"/>
                 </a:solidFill>
               </a14:hiddenFill>
             </a:ext>
             <a:ext uri="{FAA26D3D-D897-4be2-8F04-BA451C77F1D7}">
-              <ma14:placeholderFlag xmlns:ma14="http://schemas.microsoft.com/office/mac/drawingml/2011/main" xmlns="" val="1"/>
+              <ma14:placeholderFlag xmlns="" xmlns:ma14="http://schemas.microsoft.com/office/mac/drawingml/2011/main" val="1"/>
             </a:ext>
           </a:extLst>
         </p:spPr>
@@ -907,14 +907,14 @@
           <a:ln w="9525"/>
           <a:extLst>
             <a:ext uri="{909E8E84-426E-40dd-AFC4-6F175D3DCCD1}">
-              <a14:hiddenFill xmlns:a14="http://schemas.microsoft.com/office/drawing/2010/main" xmlns="">
+              <a14:hiddenFill xmlns="" xmlns:a14="http://schemas.microsoft.com/office/drawing/2010/main">
                 <a:solidFill>
                   <a:srgbClr val="FFFFFF"/>
                 </a:solidFill>
               </a14:hiddenFill>
             </a:ext>
             <a:ext uri="{91240B29-F687-4f45-9708-019B960494DF}">
-              <a14:hiddenLine xmlns:a14="http://schemas.microsoft.com/office/drawing/2010/main" xmlns="" w="12700" cap="sq">
+              <a14:hiddenLine xmlns="" xmlns:a14="http://schemas.microsoft.com/office/drawing/2010/main" w="12700" cap="sq">
                 <a:solidFill>
                   <a:srgbClr val="000000"/>
                 </a:solidFill>
@@ -1078,14 +1078,14 @@
           <a:ln w="9525"/>
           <a:extLst>
             <a:ext uri="{909E8E84-426E-40dd-AFC4-6F175D3DCCD1}">
-              <a14:hiddenFill xmlns:a14="http://schemas.microsoft.com/office/drawing/2010/main" xmlns="">
+              <a14:hiddenFill xmlns="" xmlns:a14="http://schemas.microsoft.com/office/drawing/2010/main">
                 <a:solidFill>
                   <a:srgbClr val="FFFFFF"/>
                 </a:solidFill>
               </a14:hiddenFill>
             </a:ext>
             <a:ext uri="{91240B29-F687-4f45-9708-019B960494DF}">
-              <a14:hiddenLine xmlns:a14="http://schemas.microsoft.com/office/drawing/2010/main" xmlns="" w="9525" cap="sq">
+              <a14:hiddenLine xmlns="" xmlns:a14="http://schemas.microsoft.com/office/drawing/2010/main" w="9525" cap="sq">
                 <a:solidFill>
                   <a:srgbClr val="000000"/>
                 </a:solidFill>
@@ -1095,7 +1095,7 @@
               </a14:hiddenLine>
             </a:ext>
             <a:ext uri="{FAA26D3D-D897-4be2-8F04-BA451C77F1D7}">
-              <ma14:placeholderFlag xmlns:ma14="http://schemas.microsoft.com/office/mac/drawingml/2011/main" xmlns="" val="1"/>
+              <ma14:placeholderFlag xmlns="" xmlns:ma14="http://schemas.microsoft.com/office/mac/drawingml/2011/main" val="1"/>
             </a:ext>
           </a:extLst>
         </p:spPr>
@@ -1394,7 +1394,7 @@
             <a:fld id="{08B9EBBA-996F-894A-B54A-D6246ED52CEA}" type="datetimeFigureOut">
               <a:rPr lang="en-US" smtClean="0"/>
               <a:pPr/>
-              <a:t>2/5/26</a:t>
+              <a:t>2/19/26</a:t>
             </a:fld>
             <a:endParaRPr lang="en-US" dirty="0"/>
           </a:p>
@@ -1816,7 +1816,7 @@
             <a:fld id="{09B482E8-6E0E-1B4F-B1FD-C69DB9E858D9}" type="datetimeFigureOut">
               <a:rPr lang="en-US" smtClean="0"/>
               <a:pPr/>
-              <a:t>2/5/26</a:t>
+              <a:t>2/19/26</a:t>
             </a:fld>
             <a:endParaRPr lang="en-US" dirty="0"/>
           </a:p>
@@ -2160,7 +2160,7 @@
             <a:fld id="{09B482E8-6E0E-1B4F-B1FD-C69DB9E858D9}" type="datetimeFigureOut">
               <a:rPr lang="en-US" smtClean="0"/>
               <a:pPr/>
-              <a:t>2/5/26</a:t>
+              <a:t>2/19/26</a:t>
             </a:fld>
             <a:endParaRPr lang="en-US" dirty="0"/>
           </a:p>
@@ -2573,7 +2573,7 @@
             <a:fld id="{09B482E8-6E0E-1B4F-B1FD-C69DB9E858D9}" type="datetimeFigureOut">
               <a:rPr lang="en-US" smtClean="0"/>
               <a:pPr/>
-              <a:t>2/5/26</a:t>
+              <a:t>2/19/26</a:t>
             </a:fld>
             <a:endParaRPr lang="en-US" dirty="0"/>
           </a:p>
@@ -3149,7 +3149,7 @@
             <a:fld id="{09B482E8-6E0E-1B4F-B1FD-C69DB9E858D9}" type="datetimeFigureOut">
               <a:rPr lang="en-US" smtClean="0"/>
               <a:pPr/>
-              <a:t>2/5/26</a:t>
+              <a:t>2/19/26</a:t>
             </a:fld>
             <a:endParaRPr lang="en-US" dirty="0"/>
           </a:p>
@@ -3838,7 +3838,7 @@
             <a:fld id="{09B482E8-6E0E-1B4F-B1FD-C69DB9E858D9}" type="datetimeFigureOut">
               <a:rPr lang="en-US" smtClean="0"/>
               <a:pPr/>
-              <a:t>2/5/26</a:t>
+              <a:t>2/19/26</a:t>
             </a:fld>
             <a:endParaRPr lang="en-US" dirty="0"/>
           </a:p>
@@ -4759,7 +4759,7 @@
             <a:fld id="{09B482E8-6E0E-1B4F-B1FD-C69DB9E858D9}" type="datetimeFigureOut">
               <a:rPr lang="en-US" smtClean="0"/>
               <a:pPr/>
-              <a:t>2/5/26</a:t>
+              <a:t>2/19/26</a:t>
             </a:fld>
             <a:endParaRPr lang="en-US" dirty="0"/>
           </a:p>
@@ -5080,7 +5080,7 @@
             <a:fld id="{09B482E8-6E0E-1B4F-B1FD-C69DB9E858D9}" type="datetimeFigureOut">
               <a:rPr lang="en-US" smtClean="0"/>
               <a:pPr/>
-              <a:t>2/5/26</a:t>
+              <a:t>2/19/26</a:t>
             </a:fld>
             <a:endParaRPr lang="en-US" dirty="0"/>
           </a:p>
@@ -5351,7 +5351,7 @@
             <a:fld id="{09B482E8-6E0E-1B4F-B1FD-C69DB9E858D9}" type="datetimeFigureOut">
               <a:rPr lang="en-US" smtClean="0"/>
               <a:pPr/>
-              <a:t>2/5/26</a:t>
+              <a:t>2/19/26</a:t>
             </a:fld>
             <a:endParaRPr lang="en-US" dirty="0"/>
           </a:p>
@@ -5681,7 +5681,7 @@
             <a:fld id="{09B482E8-6E0E-1B4F-B1FD-C69DB9E858D9}" type="datetimeFigureOut">
               <a:rPr lang="en-US" smtClean="0"/>
               <a:pPr/>
-              <a:t>2/5/26</a:t>
+              <a:t>2/19/26</a:t>
             </a:fld>
             <a:endParaRPr lang="en-US" dirty="0"/>
           </a:p>
@@ -6077,7 +6077,7 @@
             <a:fld id="{8DFA1846-DA80-1C48-A609-854EA85C59AD}" type="datetimeFigureOut">
               <a:rPr lang="en-US" smtClean="0"/>
               <a:pPr/>
-              <a:t>2/5/26</a:t>
+              <a:t>2/19/26</a:t>
             </a:fld>
             <a:endParaRPr lang="en-US" dirty="0"/>
           </a:p>
@@ -6460,7 +6460,7 @@
             <a:fld id="{09B482E8-6E0E-1B4F-B1FD-C69DB9E858D9}" type="datetimeFigureOut">
               <a:rPr lang="en-US" smtClean="0"/>
               <a:pPr/>
-              <a:t>2/5/26</a:t>
+              <a:t>2/19/26</a:t>
             </a:fld>
             <a:endParaRPr lang="en-US" dirty="0"/>
           </a:p>
@@ -6973,7 +6973,7 @@
             <a:fld id="{09B482E8-6E0E-1B4F-B1FD-C69DB9E858D9}" type="datetimeFigureOut">
               <a:rPr lang="en-US" smtClean="0"/>
               <a:pPr/>
-              <a:t>2/5/26</a:t>
+              <a:t>2/19/26</a:t>
             </a:fld>
             <a:endParaRPr lang="en-US" dirty="0"/>
           </a:p>
@@ -7251,7 +7251,7 @@
             <a:fld id="{F13A34C8-038E-2045-AF43-DF7DBB8E0E9E}" type="datetimeFigureOut">
               <a:rPr lang="en-US" smtClean="0"/>
               <a:pPr/>
-              <a:t>2/5/26</a:t>
+              <a:t>2/19/26</a:t>
             </a:fld>
             <a:endParaRPr lang="en-US" dirty="0"/>
           </a:p>
@@ -7428,7 +7428,7 @@
             <a:fld id="{8818C68F-D26B-8F47-958C-23B49CF8A634}" type="datetimeFigureOut">
               <a:rPr lang="en-US" smtClean="0"/>
               <a:pPr/>
-              <a:t>2/5/26</a:t>
+              <a:t>2/19/26</a:t>
             </a:fld>
             <a:endParaRPr lang="en-US" dirty="0"/>
           </a:p>
@@ -7825,7 +7825,7 @@
             <a:fld id="{09B482E8-6E0E-1B4F-B1FD-C69DB9E858D9}" type="datetimeFigureOut">
               <a:rPr lang="en-US" smtClean="0"/>
               <a:pPr/>
-              <a:t>2/5/26</a:t>
+              <a:t>2/19/26</a:t>
             </a:fld>
             <a:endParaRPr lang="en-US" dirty="0"/>
           </a:p>
@@ -8241,7 +8241,7 @@
             <a:fld id="{09B482E8-6E0E-1B4F-B1FD-C69DB9E858D9}" type="datetimeFigureOut">
               <a:rPr lang="en-US" smtClean="0"/>
               <a:pPr/>
-              <a:t>2/5/26</a:t>
+              <a:t>2/19/26</a:t>
             </a:fld>
             <a:endParaRPr lang="en-US" dirty="0"/>
           </a:p>
@@ -8492,7 +8492,7 @@
             <a:fld id="{09B482E8-6E0E-1B4F-B1FD-C69DB9E858D9}" type="datetimeFigureOut">
               <a:rPr lang="en-US" smtClean="0"/>
               <a:pPr/>
-              <a:t>2/5/26</a:t>
+              <a:t>2/19/26</a:t>
             </a:fld>
             <a:endParaRPr lang="en-US" dirty="0"/>
           </a:p>
@@ -8930,14 +8930,14 @@
           <a:ln/>
           <a:extLst>
             <a:ext uri="{909E8E84-426E-40dd-AFC4-6F175D3DCCD1}">
-              <a14:hiddenFill xmlns:a14="http://schemas.microsoft.com/office/drawing/2010/main" xmlns="">
+              <a14:hiddenFill xmlns="" xmlns:a14="http://schemas.microsoft.com/office/drawing/2010/main">
                 <a:solidFill>
                   <a:srgbClr val="FFFFFF"/>
                 </a:solidFill>
               </a14:hiddenFill>
             </a:ext>
             <a:ext uri="{91240B29-F687-4f45-9708-019B960494DF}">
-              <a14:hiddenLine xmlns:a14="http://schemas.microsoft.com/office/drawing/2010/main" xmlns="" w="9525">
+              <a14:hiddenLine xmlns="" xmlns:a14="http://schemas.microsoft.com/office/drawing/2010/main" w="9525">
                 <a:solidFill>
                   <a:srgbClr val="000000"/>
                 </a:solidFill>
@@ -9090,14 +9090,14 @@
           </a:ln>
           <a:extLst>
             <a:ext uri="{909E8E84-426E-40dd-AFC4-6F175D3DCCD1}">
-              <a14:hiddenFill xmlns:a14="http://schemas.microsoft.com/office/drawing/2010/main" xmlns="">
+              <a14:hiddenFill xmlns="" xmlns:a14="http://schemas.microsoft.com/office/drawing/2010/main">
                 <a:solidFill>
                   <a:srgbClr val="FFFFFF"/>
                 </a:solidFill>
               </a14:hiddenFill>
             </a:ext>
             <a:ext uri="{91240B29-F687-4f45-9708-019B960494DF}">
-              <a14:hiddenLine xmlns:a14="http://schemas.microsoft.com/office/drawing/2010/main" xmlns="" w="9525">
+              <a14:hiddenLine xmlns="" xmlns:a14="http://schemas.microsoft.com/office/drawing/2010/main" w="9525">
                 <a:solidFill>
                   <a:srgbClr val="000000"/>
                 </a:solidFill>
@@ -9256,14 +9256,14 @@
           </a:ln>
           <a:extLst>
             <a:ext uri="{909E8E84-426E-40dd-AFC4-6F175D3DCCD1}">
-              <a14:hiddenFill xmlns:a14="http://schemas.microsoft.com/office/drawing/2010/main" xmlns="">
+              <a14:hiddenFill xmlns="" xmlns:a14="http://schemas.microsoft.com/office/drawing/2010/main">
                 <a:solidFill>
                   <a:srgbClr val="FFFFFF"/>
                 </a:solidFill>
               </a14:hiddenFill>
             </a:ext>
             <a:ext uri="{91240B29-F687-4f45-9708-019B960494DF}">
-              <a14:hiddenLine xmlns:a14="http://schemas.microsoft.com/office/drawing/2010/main" xmlns="" w="9525">
+              <a14:hiddenLine xmlns="" xmlns:a14="http://schemas.microsoft.com/office/drawing/2010/main" w="9525">
                 <a:solidFill>
                   <a:srgbClr val="000000"/>
                 </a:solidFill>
@@ -9321,14 +9321,14 @@
           </a:ln>
           <a:extLst>
             <a:ext uri="{909E8E84-426E-40dd-AFC4-6F175D3DCCD1}">
-              <a14:hiddenFill xmlns:a14="http://schemas.microsoft.com/office/drawing/2010/main" xmlns="">
+              <a14:hiddenFill xmlns="" xmlns:a14="http://schemas.microsoft.com/office/drawing/2010/main">
                 <a:solidFill>
                   <a:srgbClr val="FFFFFF"/>
                 </a:solidFill>
               </a14:hiddenFill>
             </a:ext>
             <a:ext uri="{91240B29-F687-4f45-9708-019B960494DF}">
-              <a14:hiddenLine xmlns:a14="http://schemas.microsoft.com/office/drawing/2010/main" xmlns="" w="9525">
+              <a14:hiddenLine xmlns="" xmlns:a14="http://schemas.microsoft.com/office/drawing/2010/main" w="9525">
                 <a:solidFill>
                   <a:srgbClr val="000000"/>
                 </a:solidFill>
@@ -9380,14 +9380,14 @@
           <a:ln/>
           <a:extLst>
             <a:ext uri="{909E8E84-426E-40dd-AFC4-6F175D3DCCD1}">
-              <a14:hiddenFill xmlns:a14="http://schemas.microsoft.com/office/drawing/2010/main" xmlns="">
+              <a14:hiddenFill xmlns="" xmlns:a14="http://schemas.microsoft.com/office/drawing/2010/main">
                 <a:solidFill>
                   <a:srgbClr val="FFFFFF"/>
                 </a:solidFill>
               </a14:hiddenFill>
             </a:ext>
             <a:ext uri="{91240B29-F687-4f45-9708-019B960494DF}">
-              <a14:hiddenLine xmlns:a14="http://schemas.microsoft.com/office/drawing/2010/main" xmlns="" w="9525">
+              <a14:hiddenLine xmlns="" xmlns:a14="http://schemas.microsoft.com/office/drawing/2010/main" w="9525">
                 <a:solidFill>
                   <a:srgbClr val="000000"/>
                 </a:solidFill>
@@ -9544,7 +9544,7 @@
           </a:ln>
           <a:extLst>
             <a:ext uri="{91240B29-F687-4f45-9708-019B960494DF}">
-              <a14:hiddenLine xmlns:a14="http://schemas.microsoft.com/office/drawing/2010/main" xmlns="" w="12700" cap="sq">
+              <a14:hiddenLine xmlns="" xmlns:a14="http://schemas.microsoft.com/office/drawing/2010/main" w="12700" cap="sq">
                 <a:solidFill>
                   <a:srgbClr val="000000"/>
                 </a:solidFill>
@@ -9763,14 +9763,14 @@
           </a:ln>
           <a:extLst>
             <a:ext uri="{909E8E84-426E-40dd-AFC4-6F175D3DCCD1}">
-              <a14:hiddenFill xmlns:a14="http://schemas.microsoft.com/office/drawing/2010/main" xmlns="">
+              <a14:hiddenFill xmlns="" xmlns:a14="http://schemas.microsoft.com/office/drawing/2010/main">
                 <a:solidFill>
                   <a:srgbClr val="FFFFFF"/>
                 </a:solidFill>
               </a14:hiddenFill>
             </a:ext>
             <a:ext uri="{91240B29-F687-4f45-9708-019B960494DF}">
-              <a14:hiddenLine xmlns:a14="http://schemas.microsoft.com/office/drawing/2010/main" xmlns="" w="12700" cap="sq">
+              <a14:hiddenLine xmlns="" xmlns:a14="http://schemas.microsoft.com/office/drawing/2010/main" w="12700" cap="sq">
                 <a:solidFill>
                   <a:srgbClr val="000000"/>
                 </a:solidFill>
@@ -9931,14 +9931,14 @@
           </a:ln>
           <a:extLst>
             <a:ext uri="{909E8E84-426E-40dd-AFC4-6F175D3DCCD1}">
-              <a14:hiddenFill xmlns:a14="http://schemas.microsoft.com/office/drawing/2010/main" xmlns="">
+              <a14:hiddenFill xmlns="" xmlns:a14="http://schemas.microsoft.com/office/drawing/2010/main">
                 <a:solidFill>
                   <a:srgbClr val="FFFFFF"/>
                 </a:solidFill>
               </a14:hiddenFill>
             </a:ext>
             <a:ext uri="{91240B29-F687-4f45-9708-019B960494DF}">
-              <a14:hiddenLine xmlns:a14="http://schemas.microsoft.com/office/drawing/2010/main" xmlns="" w="12700" cap="sq">
+              <a14:hiddenLine xmlns="" xmlns:a14="http://schemas.microsoft.com/office/drawing/2010/main" w="12700" cap="sq">
                 <a:solidFill>
                   <a:srgbClr val="000000"/>
                 </a:solidFill>
@@ -10095,7 +10095,7 @@
           </a:ln>
           <a:extLst>
             <a:ext uri="{91240B29-F687-4f45-9708-019B960494DF}">
-              <a14:hiddenLine xmlns:a14="http://schemas.microsoft.com/office/drawing/2010/main" xmlns="" w="12700" cap="sq">
+              <a14:hiddenLine xmlns="" xmlns:a14="http://schemas.microsoft.com/office/drawing/2010/main" w="12700" cap="sq">
                 <a:solidFill>
                   <a:srgbClr val="000000"/>
                 </a:solidFill>
@@ -10535,14 +10535,14 @@
           <a:ln/>
           <a:extLst>
             <a:ext uri="{909E8E84-426E-40dd-AFC4-6F175D3DCCD1}">
-              <a14:hiddenFill xmlns:a14="http://schemas.microsoft.com/office/drawing/2010/main" xmlns="">
+              <a14:hiddenFill xmlns="" xmlns:a14="http://schemas.microsoft.com/office/drawing/2010/main">
                 <a:solidFill>
                   <a:srgbClr val="FFFFFF"/>
                 </a:solidFill>
               </a14:hiddenFill>
             </a:ext>
             <a:ext uri="{91240B29-F687-4f45-9708-019B960494DF}">
-              <a14:hiddenLine xmlns:a14="http://schemas.microsoft.com/office/drawing/2010/main" xmlns="" w="9525">
+              <a14:hiddenLine xmlns="" xmlns:a14="http://schemas.microsoft.com/office/drawing/2010/main" w="9525">
                 <a:solidFill>
                   <a:srgbClr val="000000"/>
                 </a:solidFill>
@@ -10695,14 +10695,14 @@
           </a:ln>
           <a:extLst>
             <a:ext uri="{909E8E84-426E-40dd-AFC4-6F175D3DCCD1}">
-              <a14:hiddenFill xmlns:a14="http://schemas.microsoft.com/office/drawing/2010/main" xmlns="">
+              <a14:hiddenFill xmlns="" xmlns:a14="http://schemas.microsoft.com/office/drawing/2010/main">
                 <a:solidFill>
                   <a:srgbClr val="FFFFFF"/>
                 </a:solidFill>
               </a14:hiddenFill>
             </a:ext>
             <a:ext uri="{91240B29-F687-4f45-9708-019B960494DF}">
-              <a14:hiddenLine xmlns:a14="http://schemas.microsoft.com/office/drawing/2010/main" xmlns="" w="12700" cap="sq">
+              <a14:hiddenLine xmlns="" xmlns:a14="http://schemas.microsoft.com/office/drawing/2010/main" w="12700" cap="sq">
                 <a:solidFill>
                   <a:srgbClr val="000000"/>
                 </a:solidFill>
@@ -10867,7 +10867,7 @@
           </a:ln>
           <a:extLst>
             <a:ext uri="{91240B29-F687-4f45-9708-019B960494DF}">
-              <a14:hiddenLine xmlns:a14="http://schemas.microsoft.com/office/drawing/2010/main" xmlns="" w="12700" cap="sq">
+              <a14:hiddenLine xmlns="" xmlns:a14="http://schemas.microsoft.com/office/drawing/2010/main" w="12700" cap="sq">
                 <a:solidFill>
                   <a:srgbClr val="000000"/>
                 </a:solidFill>
@@ -11057,14 +11057,14 @@
           </a:ln>
           <a:extLst>
             <a:ext uri="{909E8E84-426E-40dd-AFC4-6F175D3DCCD1}">
-              <a14:hiddenFill xmlns:a14="http://schemas.microsoft.com/office/drawing/2010/main" xmlns="">
+              <a14:hiddenFill xmlns="" xmlns:a14="http://schemas.microsoft.com/office/drawing/2010/main">
                 <a:solidFill>
                   <a:srgbClr val="FFFFFF"/>
                 </a:solidFill>
               </a14:hiddenFill>
             </a:ext>
             <a:ext uri="{91240B29-F687-4f45-9708-019B960494DF}">
-              <a14:hiddenLine xmlns:a14="http://schemas.microsoft.com/office/drawing/2010/main" xmlns="" w="12700" cap="sq">
+              <a14:hiddenLine xmlns="" xmlns:a14="http://schemas.microsoft.com/office/drawing/2010/main" w="12700" cap="sq">
                 <a:solidFill>
                   <a:srgbClr val="000000"/>
                 </a:solidFill>
@@ -11221,7 +11221,7 @@
           </a:ln>
           <a:extLst>
             <a:ext uri="{91240B29-F687-4f45-9708-019B960494DF}">
-              <a14:hiddenLine xmlns:a14="http://schemas.microsoft.com/office/drawing/2010/main" xmlns="" w="12700" cap="sq">
+              <a14:hiddenLine xmlns="" xmlns:a14="http://schemas.microsoft.com/office/drawing/2010/main" w="12700" cap="sq">
                 <a:solidFill>
                   <a:srgbClr val="000000"/>
                 </a:solidFill>
@@ -11725,14 +11725,14 @@
           <a:ln/>
           <a:extLst>
             <a:ext uri="{909E8E84-426E-40dd-AFC4-6F175D3DCCD1}">
-              <a14:hiddenFill xmlns:a14="http://schemas.microsoft.com/office/drawing/2010/main" xmlns="">
+              <a14:hiddenFill xmlns="" xmlns:a14="http://schemas.microsoft.com/office/drawing/2010/main">
                 <a:solidFill>
                   <a:srgbClr val="FFFFFF"/>
                 </a:solidFill>
               </a14:hiddenFill>
             </a:ext>
             <a:ext uri="{91240B29-F687-4f45-9708-019B960494DF}">
-              <a14:hiddenLine xmlns:a14="http://schemas.microsoft.com/office/drawing/2010/main" xmlns="" w="9525">
+              <a14:hiddenLine xmlns="" xmlns:a14="http://schemas.microsoft.com/office/drawing/2010/main" w="9525">
                 <a:solidFill>
                   <a:srgbClr val="000000"/>
                 </a:solidFill>
@@ -11885,14 +11885,14 @@
           </a:ln>
           <a:extLst>
             <a:ext uri="{909E8E84-426E-40dd-AFC4-6F175D3DCCD1}">
-              <a14:hiddenFill xmlns:a14="http://schemas.microsoft.com/office/drawing/2010/main" xmlns="">
+              <a14:hiddenFill xmlns="" xmlns:a14="http://schemas.microsoft.com/office/drawing/2010/main">
                 <a:solidFill>
                   <a:srgbClr val="FFFFFF"/>
                 </a:solidFill>
               </a14:hiddenFill>
             </a:ext>
             <a:ext uri="{91240B29-F687-4f45-9708-019B960494DF}">
-              <a14:hiddenLine xmlns:a14="http://schemas.microsoft.com/office/drawing/2010/main" xmlns="" w="12700" cap="sq">
+              <a14:hiddenLine xmlns="" xmlns:a14="http://schemas.microsoft.com/office/drawing/2010/main" w="12700" cap="sq">
                 <a:solidFill>
                   <a:srgbClr val="000000"/>
                 </a:solidFill>
@@ -12057,7 +12057,7 @@
           </a:ln>
           <a:extLst>
             <a:ext uri="{91240B29-F687-4f45-9708-019B960494DF}">
-              <a14:hiddenLine xmlns:a14="http://schemas.microsoft.com/office/drawing/2010/main" xmlns="" w="12700" cap="sq">
+              <a14:hiddenLine xmlns="" xmlns:a14="http://schemas.microsoft.com/office/drawing/2010/main" w="12700" cap="sq">
                 <a:solidFill>
                   <a:srgbClr val="000000"/>
                 </a:solidFill>
@@ -12256,14 +12256,14 @@
           </a:ln>
           <a:extLst>
             <a:ext uri="{909E8E84-426E-40dd-AFC4-6F175D3DCCD1}">
-              <a14:hiddenFill xmlns:a14="http://schemas.microsoft.com/office/drawing/2010/main" xmlns="">
+              <a14:hiddenFill xmlns="" xmlns:a14="http://schemas.microsoft.com/office/drawing/2010/main">
                 <a:solidFill>
                   <a:srgbClr val="FFFFFF"/>
                 </a:solidFill>
               </a14:hiddenFill>
             </a:ext>
             <a:ext uri="{91240B29-F687-4f45-9708-019B960494DF}">
-              <a14:hiddenLine xmlns:a14="http://schemas.microsoft.com/office/drawing/2010/main" xmlns="" w="12700" cap="sq">
+              <a14:hiddenLine xmlns="" xmlns:a14="http://schemas.microsoft.com/office/drawing/2010/main" w="12700" cap="sq">
                 <a:solidFill>
                   <a:srgbClr val="000000"/>
                 </a:solidFill>
@@ -12420,7 +12420,7 @@
           </a:ln>
           <a:extLst>
             <a:ext uri="{91240B29-F687-4f45-9708-019B960494DF}">
-              <a14:hiddenLine xmlns:a14="http://schemas.microsoft.com/office/drawing/2010/main" xmlns="" w="12700" cap="sq">
+              <a14:hiddenLine xmlns="" xmlns:a14="http://schemas.microsoft.com/office/drawing/2010/main" w="12700" cap="sq">
                 <a:solidFill>
                   <a:srgbClr val="000000"/>
                 </a:solidFill>
@@ -12997,14 +12997,14 @@
           <a:ln/>
           <a:extLst>
             <a:ext uri="{909E8E84-426E-40dd-AFC4-6F175D3DCCD1}">
-              <a14:hiddenFill xmlns:a14="http://schemas.microsoft.com/office/drawing/2010/main" xmlns="">
+              <a14:hiddenFill xmlns="" xmlns:a14="http://schemas.microsoft.com/office/drawing/2010/main">
                 <a:solidFill>
                   <a:srgbClr val="FFFFFF"/>
                 </a:solidFill>
               </a14:hiddenFill>
             </a:ext>
             <a:ext uri="{91240B29-F687-4f45-9708-019B960494DF}">
-              <a14:hiddenLine xmlns:a14="http://schemas.microsoft.com/office/drawing/2010/main" xmlns="" w="9525">
+              <a14:hiddenLine xmlns="" xmlns:a14="http://schemas.microsoft.com/office/drawing/2010/main" w="9525">
                 <a:solidFill>
                   <a:srgbClr val="000000"/>
                 </a:solidFill>
@@ -13157,14 +13157,14 @@
           </a:ln>
           <a:extLst>
             <a:ext uri="{909E8E84-426E-40dd-AFC4-6F175D3DCCD1}">
-              <a14:hiddenFill xmlns:a14="http://schemas.microsoft.com/office/drawing/2010/main" xmlns="">
+              <a14:hiddenFill xmlns="" xmlns:a14="http://schemas.microsoft.com/office/drawing/2010/main">
                 <a:solidFill>
                   <a:srgbClr val="FFFFFF"/>
                 </a:solidFill>
               </a14:hiddenFill>
             </a:ext>
             <a:ext uri="{91240B29-F687-4f45-9708-019B960494DF}">
-              <a14:hiddenLine xmlns:a14="http://schemas.microsoft.com/office/drawing/2010/main" xmlns="" w="12700" cap="sq">
+              <a14:hiddenLine xmlns="" xmlns:a14="http://schemas.microsoft.com/office/drawing/2010/main" w="12700" cap="sq">
                 <a:solidFill>
                   <a:srgbClr val="000000"/>
                 </a:solidFill>
@@ -13329,7 +13329,7 @@
           </a:ln>
           <a:extLst>
             <a:ext uri="{91240B29-F687-4f45-9708-019B960494DF}">
-              <a14:hiddenLine xmlns:a14="http://schemas.microsoft.com/office/drawing/2010/main" xmlns="" w="12700" cap="sq">
+              <a14:hiddenLine xmlns="" xmlns:a14="http://schemas.microsoft.com/office/drawing/2010/main" w="12700" cap="sq">
                 <a:solidFill>
                   <a:srgbClr val="000000"/>
                 </a:solidFill>
@@ -13522,14 +13522,14 @@
           </a:ln>
           <a:extLst>
             <a:ext uri="{909E8E84-426E-40dd-AFC4-6F175D3DCCD1}">
-              <a14:hiddenFill xmlns:a14="http://schemas.microsoft.com/office/drawing/2010/main" xmlns="">
+              <a14:hiddenFill xmlns="" xmlns:a14="http://schemas.microsoft.com/office/drawing/2010/main">
                 <a:solidFill>
                   <a:srgbClr val="FFFFFF"/>
                 </a:solidFill>
               </a14:hiddenFill>
             </a:ext>
             <a:ext uri="{91240B29-F687-4f45-9708-019B960494DF}">
-              <a14:hiddenLine xmlns:a14="http://schemas.microsoft.com/office/drawing/2010/main" xmlns="" w="12700" cap="sq">
+              <a14:hiddenLine xmlns="" xmlns:a14="http://schemas.microsoft.com/office/drawing/2010/main" w="12700" cap="sq">
                 <a:solidFill>
                   <a:srgbClr val="000000"/>
                 </a:solidFill>
@@ -13686,7 +13686,7 @@
           </a:ln>
           <a:extLst>
             <a:ext uri="{91240B29-F687-4f45-9708-019B960494DF}">
-              <a14:hiddenLine xmlns:a14="http://schemas.microsoft.com/office/drawing/2010/main" xmlns="" w="12700" cap="sq">
+              <a14:hiddenLine xmlns="" xmlns:a14="http://schemas.microsoft.com/office/drawing/2010/main" w="12700" cap="sq">
                 <a:solidFill>
                   <a:srgbClr val="000000"/>
                 </a:solidFill>
@@ -14337,14 +14337,14 @@
           <a:ln/>
           <a:extLst>
             <a:ext uri="{909E8E84-426E-40dd-AFC4-6F175D3DCCD1}">
-              <a14:hiddenFill xmlns:a14="http://schemas.microsoft.com/office/drawing/2010/main" xmlns="">
+              <a14:hiddenFill xmlns="" xmlns:a14="http://schemas.microsoft.com/office/drawing/2010/main">
                 <a:solidFill>
                   <a:srgbClr val="FFFFFF"/>
                 </a:solidFill>
               </a14:hiddenFill>
             </a:ext>
             <a:ext uri="{91240B29-F687-4f45-9708-019B960494DF}">
-              <a14:hiddenLine xmlns:a14="http://schemas.microsoft.com/office/drawing/2010/main" xmlns="" w="9525">
+              <a14:hiddenLine xmlns="" xmlns:a14="http://schemas.microsoft.com/office/drawing/2010/main" w="9525">
                 <a:solidFill>
                   <a:srgbClr val="000000"/>
                 </a:solidFill>
@@ -14497,14 +14497,14 @@
           </a:ln>
           <a:extLst>
             <a:ext uri="{909E8E84-426E-40dd-AFC4-6F175D3DCCD1}">
-              <a14:hiddenFill xmlns:a14="http://schemas.microsoft.com/office/drawing/2010/main" xmlns="">
+              <a14:hiddenFill xmlns="" xmlns:a14="http://schemas.microsoft.com/office/drawing/2010/main">
                 <a:solidFill>
                   <a:srgbClr val="FFFFFF"/>
                 </a:solidFill>
               </a14:hiddenFill>
             </a:ext>
             <a:ext uri="{91240B29-F687-4f45-9708-019B960494DF}">
-              <a14:hiddenLine xmlns:a14="http://schemas.microsoft.com/office/drawing/2010/main" xmlns="" w="12700" cap="sq">
+              <a14:hiddenLine xmlns="" xmlns:a14="http://schemas.microsoft.com/office/drawing/2010/main" w="12700" cap="sq">
                 <a:solidFill>
                   <a:srgbClr val="000000"/>
                 </a:solidFill>
@@ -14665,14 +14665,14 @@
           </a:ln>
           <a:extLst>
             <a:ext uri="{909E8E84-426E-40dd-AFC4-6F175D3DCCD1}">
-              <a14:hiddenFill xmlns:a14="http://schemas.microsoft.com/office/drawing/2010/main" xmlns="">
+              <a14:hiddenFill xmlns="" xmlns:a14="http://schemas.microsoft.com/office/drawing/2010/main">
                 <a:solidFill>
                   <a:srgbClr val="FFFFFF"/>
                 </a:solidFill>
               </a14:hiddenFill>
             </a:ext>
             <a:ext uri="{91240B29-F687-4f45-9708-019B960494DF}">
-              <a14:hiddenLine xmlns:a14="http://schemas.microsoft.com/office/drawing/2010/main" xmlns="" w="12700" cap="sq">
+              <a14:hiddenLine xmlns="" xmlns:a14="http://schemas.microsoft.com/office/drawing/2010/main" w="12700" cap="sq">
                 <a:solidFill>
                   <a:srgbClr val="000000"/>
                 </a:solidFill>
@@ -14827,7 +14827,7 @@
           </a:ln>
           <a:extLst>
             <a:ext uri="{91240B29-F687-4f45-9708-019B960494DF}">
-              <a14:hiddenLine xmlns:a14="http://schemas.microsoft.com/office/drawing/2010/main" xmlns="" w="12700" cap="sq">
+              <a14:hiddenLine xmlns="" xmlns:a14="http://schemas.microsoft.com/office/drawing/2010/main" w="12700" cap="sq">
                 <a:solidFill>
                   <a:srgbClr val="000000"/>
                 </a:solidFill>
@@ -15063,7 +15063,7 @@
           </a:ln>
           <a:extLst>
             <a:ext uri="{91240B29-F687-4f45-9708-019B960494DF}">
-              <a14:hiddenLine xmlns:a14="http://schemas.microsoft.com/office/drawing/2010/main" xmlns="" w="12700" cap="sq">
+              <a14:hiddenLine xmlns="" xmlns:a14="http://schemas.microsoft.com/office/drawing/2010/main" w="12700" cap="sq">
                 <a:solidFill>
                   <a:srgbClr val="000000"/>
                 </a:solidFill>
@@ -15300,7 +15300,7 @@
           </a:ln>
           <a:extLst>
             <a:ext uri="{909E8E84-426E-40dd-AFC4-6F175D3DCCD1}">
-              <a14:hiddenFill xmlns:a14="http://schemas.microsoft.com/office/drawing/2010/main" xmlns="">
+              <a14:hiddenFill xmlns="" xmlns:a14="http://schemas.microsoft.com/office/drawing/2010/main">
                 <a:solidFill>
                   <a:srgbClr val="FFFFFF"/>
                 </a:solidFill>
@@ -15792,14 +15792,14 @@
           <a:ln/>
           <a:extLst>
             <a:ext uri="{909E8E84-426E-40dd-AFC4-6F175D3DCCD1}">
-              <a14:hiddenFill xmlns:a14="http://schemas.microsoft.com/office/drawing/2010/main" xmlns="">
+              <a14:hiddenFill xmlns="" xmlns:a14="http://schemas.microsoft.com/office/drawing/2010/main">
                 <a:solidFill>
                   <a:srgbClr val="FFFFFF"/>
                 </a:solidFill>
               </a14:hiddenFill>
             </a:ext>
             <a:ext uri="{91240B29-F687-4f45-9708-019B960494DF}">
-              <a14:hiddenLine xmlns:a14="http://schemas.microsoft.com/office/drawing/2010/main" xmlns="" w="9525">
+              <a14:hiddenLine xmlns="" xmlns:a14="http://schemas.microsoft.com/office/drawing/2010/main" w="9525">
                 <a:solidFill>
                   <a:srgbClr val="000000"/>
                 </a:solidFill>
@@ -15952,14 +15952,14 @@
           </a:ln>
           <a:extLst>
             <a:ext uri="{909E8E84-426E-40dd-AFC4-6F175D3DCCD1}">
-              <a14:hiddenFill xmlns:a14="http://schemas.microsoft.com/office/drawing/2010/main" xmlns="">
+              <a14:hiddenFill xmlns="" xmlns:a14="http://schemas.microsoft.com/office/drawing/2010/main">
                 <a:solidFill>
                   <a:srgbClr val="FFFFFF"/>
                 </a:solidFill>
               </a14:hiddenFill>
             </a:ext>
             <a:ext uri="{91240B29-F687-4f45-9708-019B960494DF}">
-              <a14:hiddenLine xmlns:a14="http://schemas.microsoft.com/office/drawing/2010/main" xmlns="" w="12700" cap="sq">
+              <a14:hiddenLine xmlns="" xmlns:a14="http://schemas.microsoft.com/office/drawing/2010/main" w="12700" cap="sq">
                 <a:solidFill>
                   <a:srgbClr val="000000"/>
                 </a:solidFill>
@@ -16120,14 +16120,14 @@
           </a:ln>
           <a:extLst>
             <a:ext uri="{909E8E84-426E-40dd-AFC4-6F175D3DCCD1}">
-              <a14:hiddenFill xmlns:a14="http://schemas.microsoft.com/office/drawing/2010/main" xmlns="">
+              <a14:hiddenFill xmlns="" xmlns:a14="http://schemas.microsoft.com/office/drawing/2010/main">
                 <a:solidFill>
                   <a:srgbClr val="FFFFFF"/>
                 </a:solidFill>
               </a14:hiddenFill>
             </a:ext>
             <a:ext uri="{91240B29-F687-4f45-9708-019B960494DF}">
-              <a14:hiddenLine xmlns:a14="http://schemas.microsoft.com/office/drawing/2010/main" xmlns="" w="12700" cap="sq">
+              <a14:hiddenLine xmlns="" xmlns:a14="http://schemas.microsoft.com/office/drawing/2010/main" w="12700" cap="sq">
                 <a:solidFill>
                   <a:srgbClr val="000000"/>
                 </a:solidFill>
@@ -16284,7 +16284,7 @@
           </a:ln>
           <a:extLst>
             <a:ext uri="{91240B29-F687-4f45-9708-019B960494DF}">
-              <a14:hiddenLine xmlns:a14="http://schemas.microsoft.com/office/drawing/2010/main" xmlns="" w="12700" cap="sq">
+              <a14:hiddenLine xmlns="" xmlns:a14="http://schemas.microsoft.com/office/drawing/2010/main" w="12700" cap="sq">
                 <a:solidFill>
                   <a:srgbClr val="000000"/>
                 </a:solidFill>
@@ -16562,7 +16562,7 @@
           </a:ln>
           <a:extLst>
             <a:ext uri="{909E8E84-426E-40dd-AFC4-6F175D3DCCD1}">
-              <a14:hiddenFill xmlns:a14="http://schemas.microsoft.com/office/drawing/2010/main" xmlns="">
+              <a14:hiddenFill xmlns="" xmlns:a14="http://schemas.microsoft.com/office/drawing/2010/main">
                 <a:solidFill>
                   <a:srgbClr val="FFFFFF"/>
                 </a:solidFill>
@@ -16618,7 +16618,7 @@
           </a:ln>
           <a:extLst>
             <a:ext uri="{91240B29-F687-4f45-9708-019B960494DF}">
-              <a14:hiddenLine xmlns:a14="http://schemas.microsoft.com/office/drawing/2010/main" xmlns="" w="12700" cap="sq">
+              <a14:hiddenLine xmlns="" xmlns:a14="http://schemas.microsoft.com/office/drawing/2010/main" w="12700" cap="sq">
                 <a:solidFill>
                   <a:srgbClr val="000000"/>
                 </a:solidFill>
@@ -17324,14 +17324,14 @@
           <a:ln/>
           <a:extLst>
             <a:ext uri="{909E8E84-426E-40dd-AFC4-6F175D3DCCD1}">
-              <a14:hiddenFill xmlns:a14="http://schemas.microsoft.com/office/drawing/2010/main" xmlns="">
+              <a14:hiddenFill xmlns="" xmlns:a14="http://schemas.microsoft.com/office/drawing/2010/main">
                 <a:solidFill>
                   <a:srgbClr val="FFFFFF"/>
                 </a:solidFill>
               </a14:hiddenFill>
             </a:ext>
             <a:ext uri="{91240B29-F687-4f45-9708-019B960494DF}">
-              <a14:hiddenLine xmlns:a14="http://schemas.microsoft.com/office/drawing/2010/main" xmlns="" w="9525">
+              <a14:hiddenLine xmlns="" xmlns:a14="http://schemas.microsoft.com/office/drawing/2010/main" w="9525">
                 <a:solidFill>
                   <a:srgbClr val="000000"/>
                 </a:solidFill>
@@ -17484,14 +17484,14 @@
           </a:ln>
           <a:extLst>
             <a:ext uri="{909E8E84-426E-40dd-AFC4-6F175D3DCCD1}">
-              <a14:hiddenFill xmlns:a14="http://schemas.microsoft.com/office/drawing/2010/main" xmlns="">
+              <a14:hiddenFill xmlns="" xmlns:a14="http://schemas.microsoft.com/office/drawing/2010/main">
                 <a:solidFill>
                   <a:srgbClr val="FFFFFF"/>
                 </a:solidFill>
               </a14:hiddenFill>
             </a:ext>
             <a:ext uri="{91240B29-F687-4f45-9708-019B960494DF}">
-              <a14:hiddenLine xmlns:a14="http://schemas.microsoft.com/office/drawing/2010/main" xmlns="" w="12700" cap="sq">
+              <a14:hiddenLine xmlns="" xmlns:a14="http://schemas.microsoft.com/office/drawing/2010/main" w="12700" cap="sq">
                 <a:solidFill>
                   <a:srgbClr val="000000"/>
                 </a:solidFill>
@@ -17656,7 +17656,7 @@
           </a:ln>
           <a:extLst>
             <a:ext uri="{91240B29-F687-4f45-9708-019B960494DF}">
-              <a14:hiddenLine xmlns:a14="http://schemas.microsoft.com/office/drawing/2010/main" xmlns="" w="12700" cap="sq">
+              <a14:hiddenLine xmlns="" xmlns:a14="http://schemas.microsoft.com/office/drawing/2010/main" w="12700" cap="sq">
                 <a:solidFill>
                   <a:srgbClr val="000000"/>
                 </a:solidFill>
@@ -17978,14 +17978,14 @@
           </a:ln>
           <a:extLst>
             <a:ext uri="{909E8E84-426E-40dd-AFC4-6F175D3DCCD1}">
-              <a14:hiddenFill xmlns:a14="http://schemas.microsoft.com/office/drawing/2010/main" xmlns="">
+              <a14:hiddenFill xmlns="" xmlns:a14="http://schemas.microsoft.com/office/drawing/2010/main">
                 <a:solidFill>
                   <a:srgbClr val="FFFFFF"/>
                 </a:solidFill>
               </a14:hiddenFill>
             </a:ext>
             <a:ext uri="{91240B29-F687-4f45-9708-019B960494DF}">
-              <a14:hiddenLine xmlns:a14="http://schemas.microsoft.com/office/drawing/2010/main" xmlns="" w="12700" cap="sq">
+              <a14:hiddenLine xmlns="" xmlns:a14="http://schemas.microsoft.com/office/drawing/2010/main" w="12700" cap="sq">
                 <a:solidFill>
                   <a:srgbClr val="000000"/>
                 </a:solidFill>
@@ -18142,7 +18142,7 @@
           </a:ln>
           <a:extLst>
             <a:ext uri="{91240B29-F687-4f45-9708-019B960494DF}">
-              <a14:hiddenLine xmlns:a14="http://schemas.microsoft.com/office/drawing/2010/main" xmlns="" w="12700" cap="sq">
+              <a14:hiddenLine xmlns="" xmlns:a14="http://schemas.microsoft.com/office/drawing/2010/main" w="12700" cap="sq">
                 <a:solidFill>
                   <a:srgbClr val="000000"/>
                 </a:solidFill>
@@ -18332,7 +18332,7 @@
           </a:ln>
           <a:extLst>
             <a:ext uri="{909E8E84-426E-40dd-AFC4-6F175D3DCCD1}">
-              <a14:hiddenFill xmlns:a14="http://schemas.microsoft.com/office/drawing/2010/main" xmlns="">
+              <a14:hiddenFill xmlns="" xmlns:a14="http://schemas.microsoft.com/office/drawing/2010/main">
                 <a:solidFill>
                   <a:srgbClr val="FFFFFF"/>
                 </a:solidFill>
@@ -18822,14 +18822,14 @@
           <a:ln/>
           <a:extLst>
             <a:ext uri="{909E8E84-426E-40dd-AFC4-6F175D3DCCD1}">
-              <a14:hiddenFill xmlns:a14="http://schemas.microsoft.com/office/drawing/2010/main" xmlns="">
+              <a14:hiddenFill xmlns="" xmlns:a14="http://schemas.microsoft.com/office/drawing/2010/main">
                 <a:solidFill>
                   <a:srgbClr val="FFFFFF"/>
                 </a:solidFill>
               </a14:hiddenFill>
             </a:ext>
             <a:ext uri="{91240B29-F687-4f45-9708-019B960494DF}">
-              <a14:hiddenLine xmlns:a14="http://schemas.microsoft.com/office/drawing/2010/main" xmlns="" w="9525">
+              <a14:hiddenLine xmlns="" xmlns:a14="http://schemas.microsoft.com/office/drawing/2010/main" w="9525">
                 <a:solidFill>
                   <a:srgbClr val="000000"/>
                 </a:solidFill>
@@ -18982,14 +18982,14 @@
           </a:ln>
           <a:extLst>
             <a:ext uri="{909E8E84-426E-40dd-AFC4-6F175D3DCCD1}">
-              <a14:hiddenFill xmlns:a14="http://schemas.microsoft.com/office/drawing/2010/main" xmlns="">
+              <a14:hiddenFill xmlns="" xmlns:a14="http://schemas.microsoft.com/office/drawing/2010/main">
                 <a:solidFill>
                   <a:srgbClr val="FFFFFF"/>
                 </a:solidFill>
               </a14:hiddenFill>
             </a:ext>
             <a:ext uri="{91240B29-F687-4f45-9708-019B960494DF}">
-              <a14:hiddenLine xmlns:a14="http://schemas.microsoft.com/office/drawing/2010/main" xmlns="" w="12700" cap="sq">
+              <a14:hiddenLine xmlns="" xmlns:a14="http://schemas.microsoft.com/office/drawing/2010/main" w="12700" cap="sq">
                 <a:solidFill>
                   <a:srgbClr val="000000"/>
                 </a:solidFill>
@@ -19146,7 +19146,7 @@
           </a:ln>
           <a:extLst>
             <a:ext uri="{91240B29-F687-4f45-9708-019B960494DF}">
-              <a14:hiddenLine xmlns:a14="http://schemas.microsoft.com/office/drawing/2010/main" xmlns="" w="12700" cap="sq">
+              <a14:hiddenLine xmlns="" xmlns:a14="http://schemas.microsoft.com/office/drawing/2010/main" w="12700" cap="sq">
                 <a:solidFill>
                   <a:srgbClr val="000000"/>
                 </a:solidFill>
@@ -19326,14 +19326,14 @@
           </a:ln>
           <a:extLst>
             <a:ext uri="{909E8E84-426E-40dd-AFC4-6F175D3DCCD1}">
-              <a14:hiddenFill xmlns:a14="http://schemas.microsoft.com/office/drawing/2010/main" xmlns="">
+              <a14:hiddenFill xmlns="" xmlns:a14="http://schemas.microsoft.com/office/drawing/2010/main">
                 <a:solidFill>
                   <a:srgbClr val="FFFFFF"/>
                 </a:solidFill>
               </a14:hiddenFill>
             </a:ext>
             <a:ext uri="{91240B29-F687-4f45-9708-019B960494DF}">
-              <a14:hiddenLine xmlns:a14="http://schemas.microsoft.com/office/drawing/2010/main" xmlns="" w="12700" cap="sq">
+              <a14:hiddenLine xmlns="" xmlns:a14="http://schemas.microsoft.com/office/drawing/2010/main" w="12700" cap="sq">
                 <a:solidFill>
                   <a:srgbClr val="000000"/>
                 </a:solidFill>
@@ -19490,7 +19490,7 @@
           </a:ln>
           <a:extLst>
             <a:ext uri="{91240B29-F687-4f45-9708-019B960494DF}">
-              <a14:hiddenLine xmlns:a14="http://schemas.microsoft.com/office/drawing/2010/main" xmlns="" w="12700" cap="sq">
+              <a14:hiddenLine xmlns="" xmlns:a14="http://schemas.microsoft.com/office/drawing/2010/main" w="12700" cap="sq">
                 <a:solidFill>
                   <a:srgbClr val="000000"/>
                 </a:solidFill>
@@ -20268,14 +20268,14 @@
           <a:ln/>
           <a:extLst>
             <a:ext uri="{909E8E84-426E-40dd-AFC4-6F175D3DCCD1}">
-              <a14:hiddenFill xmlns:a14="http://schemas.microsoft.com/office/drawing/2010/main" xmlns="">
+              <a14:hiddenFill xmlns="" xmlns:a14="http://schemas.microsoft.com/office/drawing/2010/main">
                 <a:solidFill>
                   <a:srgbClr val="FFFFFF"/>
                 </a:solidFill>
               </a14:hiddenFill>
             </a:ext>
             <a:ext uri="{91240B29-F687-4f45-9708-019B960494DF}">
-              <a14:hiddenLine xmlns:a14="http://schemas.microsoft.com/office/drawing/2010/main" xmlns="" w="9525">
+              <a14:hiddenLine xmlns="" xmlns:a14="http://schemas.microsoft.com/office/drawing/2010/main" w="9525">
                 <a:solidFill>
                   <a:srgbClr val="000000"/>
                 </a:solidFill>
@@ -20428,14 +20428,14 @@
           </a:ln>
           <a:extLst>
             <a:ext uri="{909E8E84-426E-40dd-AFC4-6F175D3DCCD1}">
-              <a14:hiddenFill xmlns:a14="http://schemas.microsoft.com/office/drawing/2010/main" xmlns="">
+              <a14:hiddenFill xmlns="" xmlns:a14="http://schemas.microsoft.com/office/drawing/2010/main">
                 <a:solidFill>
                   <a:srgbClr val="FFFFFF"/>
                 </a:solidFill>
               </a14:hiddenFill>
             </a:ext>
             <a:ext uri="{91240B29-F687-4f45-9708-019B960494DF}">
-              <a14:hiddenLine xmlns:a14="http://schemas.microsoft.com/office/drawing/2010/main" xmlns="" w="12700" cap="sq">
+              <a14:hiddenLine xmlns="" xmlns:a14="http://schemas.microsoft.com/office/drawing/2010/main" w="12700" cap="sq">
                 <a:solidFill>
                   <a:srgbClr val="000000"/>
                 </a:solidFill>
@@ -20600,7 +20600,7 @@
           </a:ln>
           <a:extLst>
             <a:ext uri="{91240B29-F687-4f45-9708-019B960494DF}">
-              <a14:hiddenLine xmlns:a14="http://schemas.microsoft.com/office/drawing/2010/main" xmlns="" w="12700" cap="sq">
+              <a14:hiddenLine xmlns="" xmlns:a14="http://schemas.microsoft.com/office/drawing/2010/main" w="12700" cap="sq">
                 <a:solidFill>
                   <a:srgbClr val="000000"/>
                 </a:solidFill>
@@ -20783,7 +20783,7 @@
           </a:ln>
           <a:extLst>
             <a:ext uri="{909E8E84-426E-40dd-AFC4-6F175D3DCCD1}">
-              <a14:hiddenFill xmlns:a14="http://schemas.microsoft.com/office/drawing/2010/main" xmlns="">
+              <a14:hiddenFill xmlns="" xmlns:a14="http://schemas.microsoft.com/office/drawing/2010/main">
                 <a:solidFill>
                   <a:srgbClr val="FFFFFF"/>
                 </a:solidFill>
@@ -21260,14 +21260,14 @@
           <a:ln/>
           <a:extLst>
             <a:ext uri="{909E8E84-426E-40dd-AFC4-6F175D3DCCD1}">
-              <a14:hiddenFill xmlns:a14="http://schemas.microsoft.com/office/drawing/2010/main" xmlns="">
+              <a14:hiddenFill xmlns="" xmlns:a14="http://schemas.microsoft.com/office/drawing/2010/main">
                 <a:solidFill>
                   <a:srgbClr val="FFFFFF"/>
                 </a:solidFill>
               </a14:hiddenFill>
             </a:ext>
             <a:ext uri="{91240B29-F687-4f45-9708-019B960494DF}">
-              <a14:hiddenLine xmlns:a14="http://schemas.microsoft.com/office/drawing/2010/main" xmlns="" w="9525">
+              <a14:hiddenLine xmlns="" xmlns:a14="http://schemas.microsoft.com/office/drawing/2010/main" w="9525">
                 <a:solidFill>
                   <a:srgbClr val="000000"/>
                 </a:solidFill>
@@ -21420,14 +21420,14 @@
           </a:ln>
           <a:extLst>
             <a:ext uri="{909E8E84-426E-40dd-AFC4-6F175D3DCCD1}">
-              <a14:hiddenFill xmlns:a14="http://schemas.microsoft.com/office/drawing/2010/main" xmlns="">
+              <a14:hiddenFill xmlns="" xmlns:a14="http://schemas.microsoft.com/office/drawing/2010/main">
                 <a:solidFill>
                   <a:srgbClr val="FFFFFF"/>
                 </a:solidFill>
               </a14:hiddenFill>
             </a:ext>
             <a:ext uri="{91240B29-F687-4f45-9708-019B960494DF}">
-              <a14:hiddenLine xmlns:a14="http://schemas.microsoft.com/office/drawing/2010/main" xmlns="" w="12700" cap="sq">
+              <a14:hiddenLine xmlns="" xmlns:a14="http://schemas.microsoft.com/office/drawing/2010/main" w="12700" cap="sq">
                 <a:solidFill>
                   <a:srgbClr val="000000"/>
                 </a:solidFill>
@@ -21592,7 +21592,7 @@
           </a:ln>
           <a:extLst>
             <a:ext uri="{91240B29-F687-4f45-9708-019B960494DF}">
-              <a14:hiddenLine xmlns:a14="http://schemas.microsoft.com/office/drawing/2010/main" xmlns="" w="12700" cap="sq">
+              <a14:hiddenLine xmlns="" xmlns:a14="http://schemas.microsoft.com/office/drawing/2010/main" w="12700" cap="sq">
                 <a:solidFill>
                   <a:srgbClr val="000000"/>
                 </a:solidFill>
@@ -21787,7 +21787,7 @@
           </a:ln>
           <a:extLst>
             <a:ext uri="{91240B29-F687-4f45-9708-019B960494DF}">
-              <a14:hiddenLine xmlns:a14="http://schemas.microsoft.com/office/drawing/2010/main" xmlns="" w="12700" cap="sq">
+              <a14:hiddenLine xmlns="" xmlns:a14="http://schemas.microsoft.com/office/drawing/2010/main" w="12700" cap="sq">
                 <a:solidFill>
                   <a:srgbClr val="000000"/>
                 </a:solidFill>
@@ -21994,7 +21994,7 @@
           </a:ln>
           <a:extLst>
             <a:ext uri="{91240B29-F687-4f45-9708-019B960494DF}">
-              <a14:hiddenLine xmlns:a14="http://schemas.microsoft.com/office/drawing/2010/main" xmlns="" w="12700" cap="sq">
+              <a14:hiddenLine xmlns="" xmlns:a14="http://schemas.microsoft.com/office/drawing/2010/main" w="12700" cap="sq">
                 <a:solidFill>
                   <a:srgbClr val="000000"/>
                 </a:solidFill>
@@ -22712,14 +22712,14 @@
           <a:ln/>
           <a:extLst>
             <a:ext uri="{909E8E84-426E-40dd-AFC4-6F175D3DCCD1}">
-              <a14:hiddenFill xmlns:a14="http://schemas.microsoft.com/office/drawing/2010/main" xmlns="">
+              <a14:hiddenFill xmlns="" xmlns:a14="http://schemas.microsoft.com/office/drawing/2010/main">
                 <a:solidFill>
                   <a:srgbClr val="FFFFFF"/>
                 </a:solidFill>
               </a14:hiddenFill>
             </a:ext>
             <a:ext uri="{91240B29-F687-4f45-9708-019B960494DF}">
-              <a14:hiddenLine xmlns:a14="http://schemas.microsoft.com/office/drawing/2010/main" xmlns="" w="9525">
+              <a14:hiddenLine xmlns="" xmlns:a14="http://schemas.microsoft.com/office/drawing/2010/main" w="9525">
                 <a:solidFill>
                   <a:srgbClr val="000000"/>
                 </a:solidFill>
@@ -22872,14 +22872,14 @@
           </a:ln>
           <a:extLst>
             <a:ext uri="{909E8E84-426E-40dd-AFC4-6F175D3DCCD1}">
-              <a14:hiddenFill xmlns:a14="http://schemas.microsoft.com/office/drawing/2010/main" xmlns="">
+              <a14:hiddenFill xmlns="" xmlns:a14="http://schemas.microsoft.com/office/drawing/2010/main">
                 <a:solidFill>
                   <a:srgbClr val="FFFFFF"/>
                 </a:solidFill>
               </a14:hiddenFill>
             </a:ext>
             <a:ext uri="{91240B29-F687-4f45-9708-019B960494DF}">
-              <a14:hiddenLine xmlns:a14="http://schemas.microsoft.com/office/drawing/2010/main" xmlns="" w="12700" cap="sq">
+              <a14:hiddenLine xmlns="" xmlns:a14="http://schemas.microsoft.com/office/drawing/2010/main" w="12700" cap="sq">
                 <a:solidFill>
                   <a:srgbClr val="000000"/>
                 </a:solidFill>
@@ -23046,7 +23046,7 @@
           </a:ln>
           <a:extLst>
             <a:ext uri="{91240B29-F687-4f45-9708-019B960494DF}">
-              <a14:hiddenLine xmlns:a14="http://schemas.microsoft.com/office/drawing/2010/main" xmlns="" w="12700" cap="sq">
+              <a14:hiddenLine xmlns="" xmlns:a14="http://schemas.microsoft.com/office/drawing/2010/main" w="12700" cap="sq">
                 <a:solidFill>
                   <a:srgbClr val="000000"/>
                 </a:solidFill>
@@ -23250,7 +23250,7 @@
           </a:ln>
           <a:extLst>
             <a:ext uri="{909E8E84-426E-40dd-AFC4-6F175D3DCCD1}">
-              <a14:hiddenFill xmlns:a14="http://schemas.microsoft.com/office/drawing/2010/main" xmlns="">
+              <a14:hiddenFill xmlns="" xmlns:a14="http://schemas.microsoft.com/office/drawing/2010/main">
                 <a:solidFill>
                   <a:srgbClr val="FFFFFF"/>
                 </a:solidFill>
@@ -23564,14 +23564,14 @@
           <a:ln/>
           <a:extLst>
             <a:ext uri="{909E8E84-426E-40dd-AFC4-6F175D3DCCD1}">
-              <a14:hiddenFill xmlns:a14="http://schemas.microsoft.com/office/drawing/2010/main" xmlns="">
+              <a14:hiddenFill xmlns="" xmlns:a14="http://schemas.microsoft.com/office/drawing/2010/main">
                 <a:solidFill>
                   <a:srgbClr val="FFFFFF"/>
                 </a:solidFill>
               </a14:hiddenFill>
             </a:ext>
             <a:ext uri="{91240B29-F687-4f45-9708-019B960494DF}">
-              <a14:hiddenLine xmlns:a14="http://schemas.microsoft.com/office/drawing/2010/main" xmlns="" w="9525">
+              <a14:hiddenLine xmlns="" xmlns:a14="http://schemas.microsoft.com/office/drawing/2010/main" w="9525">
                 <a:solidFill>
                   <a:srgbClr val="000000"/>
                 </a:solidFill>
@@ -23724,14 +23724,14 @@
           </a:ln>
           <a:extLst>
             <a:ext uri="{909E8E84-426E-40dd-AFC4-6F175D3DCCD1}">
-              <a14:hiddenFill xmlns:a14="http://schemas.microsoft.com/office/drawing/2010/main" xmlns="">
+              <a14:hiddenFill xmlns="" xmlns:a14="http://schemas.microsoft.com/office/drawing/2010/main">
                 <a:solidFill>
                   <a:srgbClr val="FFFFFF"/>
                 </a:solidFill>
               </a14:hiddenFill>
             </a:ext>
             <a:ext uri="{91240B29-F687-4f45-9708-019B960494DF}">
-              <a14:hiddenLine xmlns:a14="http://schemas.microsoft.com/office/drawing/2010/main" xmlns="" w="12700" cap="sq">
+              <a14:hiddenLine xmlns="" xmlns:a14="http://schemas.microsoft.com/office/drawing/2010/main" w="12700" cap="sq">
                 <a:solidFill>
                   <a:srgbClr val="000000"/>
                 </a:solidFill>
@@ -23888,7 +23888,7 @@
           </a:ln>
           <a:extLst>
             <a:ext uri="{91240B29-F687-4f45-9708-019B960494DF}">
-              <a14:hiddenLine xmlns:a14="http://schemas.microsoft.com/office/drawing/2010/main" xmlns="" w="12700" cap="sq">
+              <a14:hiddenLine xmlns="" xmlns:a14="http://schemas.microsoft.com/office/drawing/2010/main" w="12700" cap="sq">
                 <a:solidFill>
                   <a:srgbClr val="000000"/>
                 </a:solidFill>
@@ -24172,14 +24172,14 @@
           </a:ln>
           <a:extLst>
             <a:ext uri="{909E8E84-426E-40dd-AFC4-6F175D3DCCD1}">
-              <a14:hiddenFill xmlns:a14="http://schemas.microsoft.com/office/drawing/2010/main" xmlns="">
+              <a14:hiddenFill xmlns="" xmlns:a14="http://schemas.microsoft.com/office/drawing/2010/main">
                 <a:solidFill>
                   <a:srgbClr val="FFFFFF"/>
                 </a:solidFill>
               </a14:hiddenFill>
             </a:ext>
             <a:ext uri="{91240B29-F687-4f45-9708-019B960494DF}">
-              <a14:hiddenLine xmlns:a14="http://schemas.microsoft.com/office/drawing/2010/main" xmlns="" w="12700" cap="sq">
+              <a14:hiddenLine xmlns="" xmlns:a14="http://schemas.microsoft.com/office/drawing/2010/main" w="12700" cap="sq">
                 <a:solidFill>
                   <a:srgbClr val="000000"/>
                 </a:solidFill>
@@ -24336,7 +24336,7 @@
           </a:ln>
           <a:extLst>
             <a:ext uri="{91240B29-F687-4f45-9708-019B960494DF}">
-              <a14:hiddenLine xmlns:a14="http://schemas.microsoft.com/office/drawing/2010/main" xmlns="" w="12700" cap="sq">
+              <a14:hiddenLine xmlns="" xmlns:a14="http://schemas.microsoft.com/office/drawing/2010/main" w="12700" cap="sq">
                 <a:solidFill>
                   <a:srgbClr val="000000"/>
                 </a:solidFill>
@@ -25005,14 +25005,14 @@
         <p:spPr>
           <a:extLst>
             <a:ext uri="{909E8E84-426E-40dd-AFC4-6F175D3DCCD1}">
-              <a14:hiddenFill xmlns:a14="http://schemas.microsoft.com/office/drawing/2010/main" xmlns="">
+              <a14:hiddenFill xmlns="" xmlns:a14="http://schemas.microsoft.com/office/drawing/2010/main">
                 <a:solidFill>
                   <a:srgbClr val="FFFFFF"/>
                 </a:solidFill>
               </a14:hiddenFill>
             </a:ext>
             <a:ext uri="{91240B29-F687-4f45-9708-019B960494DF}">
-              <a14:hiddenLine xmlns:a14="http://schemas.microsoft.com/office/drawing/2010/main" xmlns="" w="9525">
+              <a14:hiddenLine xmlns="" xmlns:a14="http://schemas.microsoft.com/office/drawing/2010/main" w="9525">
                 <a:solidFill>
                   <a:srgbClr val="000000"/>
                 </a:solidFill>
@@ -25266,14 +25266,14 @@
           <a:ln/>
           <a:extLst>
             <a:ext uri="{909E8E84-426E-40dd-AFC4-6F175D3DCCD1}">
-              <a14:hiddenFill xmlns:a14="http://schemas.microsoft.com/office/drawing/2010/main" xmlns="">
+              <a14:hiddenFill xmlns="" xmlns:a14="http://schemas.microsoft.com/office/drawing/2010/main">
                 <a:solidFill>
                   <a:srgbClr val="FFFFFF"/>
                 </a:solidFill>
               </a14:hiddenFill>
             </a:ext>
             <a:ext uri="{91240B29-F687-4f45-9708-019B960494DF}">
-              <a14:hiddenLine xmlns:a14="http://schemas.microsoft.com/office/drawing/2010/main" xmlns="" w="9525">
+              <a14:hiddenLine xmlns="" xmlns:a14="http://schemas.microsoft.com/office/drawing/2010/main" w="9525">
                 <a:solidFill>
                   <a:srgbClr val="000000"/>
                 </a:solidFill>
@@ -25426,14 +25426,14 @@
           </a:ln>
           <a:extLst>
             <a:ext uri="{909E8E84-426E-40dd-AFC4-6F175D3DCCD1}">
-              <a14:hiddenFill xmlns:a14="http://schemas.microsoft.com/office/drawing/2010/main" xmlns="">
+              <a14:hiddenFill xmlns="" xmlns:a14="http://schemas.microsoft.com/office/drawing/2010/main">
                 <a:solidFill>
                   <a:srgbClr val="FFFFFF"/>
                 </a:solidFill>
               </a14:hiddenFill>
             </a:ext>
             <a:ext uri="{91240B29-F687-4f45-9708-019B960494DF}">
-              <a14:hiddenLine xmlns:a14="http://schemas.microsoft.com/office/drawing/2010/main" xmlns="" w="12700" cap="sq">
+              <a14:hiddenLine xmlns="" xmlns:a14="http://schemas.microsoft.com/office/drawing/2010/main" w="12700" cap="sq">
                 <a:solidFill>
                   <a:srgbClr val="000000"/>
                 </a:solidFill>
@@ -25596,7 +25596,7 @@
           </a:ln>
           <a:extLst>
             <a:ext uri="{91240B29-F687-4f45-9708-019B960494DF}">
-              <a14:hiddenLine xmlns:a14="http://schemas.microsoft.com/office/drawing/2010/main" xmlns="" w="12700" cap="sq">
+              <a14:hiddenLine xmlns="" xmlns:a14="http://schemas.microsoft.com/office/drawing/2010/main" w="12700" cap="sq">
                 <a:solidFill>
                   <a:srgbClr val="000000"/>
                 </a:solidFill>
@@ -25780,7 +25780,7 @@
           </a:ln>
           <a:extLst>
             <a:ext uri="{909E8E84-426E-40dd-AFC4-6F175D3DCCD1}">
-              <a14:hiddenFill xmlns:a14="http://schemas.microsoft.com/office/drawing/2010/main" xmlns="">
+              <a14:hiddenFill xmlns="" xmlns:a14="http://schemas.microsoft.com/office/drawing/2010/main">
                 <a:solidFill>
                   <a:srgbClr val="FFFFFF"/>
                 </a:solidFill>
@@ -26094,14 +26094,14 @@
           <a:ln/>
           <a:extLst>
             <a:ext uri="{909E8E84-426E-40dd-AFC4-6F175D3DCCD1}">
-              <a14:hiddenFill xmlns:a14="http://schemas.microsoft.com/office/drawing/2010/main" xmlns="">
+              <a14:hiddenFill xmlns="" xmlns:a14="http://schemas.microsoft.com/office/drawing/2010/main">
                 <a:solidFill>
                   <a:srgbClr val="FFFFFF"/>
                 </a:solidFill>
               </a14:hiddenFill>
             </a:ext>
             <a:ext uri="{91240B29-F687-4f45-9708-019B960494DF}">
-              <a14:hiddenLine xmlns:a14="http://schemas.microsoft.com/office/drawing/2010/main" xmlns="" w="9525">
+              <a14:hiddenLine xmlns="" xmlns:a14="http://schemas.microsoft.com/office/drawing/2010/main" w="9525">
                 <a:solidFill>
                   <a:srgbClr val="000000"/>
                 </a:solidFill>
@@ -26254,14 +26254,14 @@
           </a:ln>
           <a:extLst>
             <a:ext uri="{909E8E84-426E-40dd-AFC4-6F175D3DCCD1}">
-              <a14:hiddenFill xmlns:a14="http://schemas.microsoft.com/office/drawing/2010/main" xmlns="">
+              <a14:hiddenFill xmlns="" xmlns:a14="http://schemas.microsoft.com/office/drawing/2010/main">
                 <a:solidFill>
                   <a:srgbClr val="FFFFFF"/>
                 </a:solidFill>
               </a14:hiddenFill>
             </a:ext>
             <a:ext uri="{91240B29-F687-4f45-9708-019B960494DF}">
-              <a14:hiddenLine xmlns:a14="http://schemas.microsoft.com/office/drawing/2010/main" xmlns="" w="12700" cap="sq">
+              <a14:hiddenLine xmlns="" xmlns:a14="http://schemas.microsoft.com/office/drawing/2010/main" w="12700" cap="sq">
                 <a:solidFill>
                   <a:srgbClr val="000000"/>
                 </a:solidFill>
@@ -26416,14 +26416,14 @@
           </a:ln>
           <a:extLst>
             <a:ext uri="{909E8E84-426E-40dd-AFC4-6F175D3DCCD1}">
-              <a14:hiddenFill xmlns:a14="http://schemas.microsoft.com/office/drawing/2010/main" xmlns="">
+              <a14:hiddenFill xmlns="" xmlns:a14="http://schemas.microsoft.com/office/drawing/2010/main">
                 <a:solidFill>
                   <a:srgbClr val="FFFFFF"/>
                 </a:solidFill>
               </a14:hiddenFill>
             </a:ext>
             <a:ext uri="{91240B29-F687-4f45-9708-019B960494DF}">
-              <a14:hiddenLine xmlns:a14="http://schemas.microsoft.com/office/drawing/2010/main" xmlns="" w="9525">
+              <a14:hiddenLine xmlns="" xmlns:a14="http://schemas.microsoft.com/office/drawing/2010/main" w="9525">
                 <a:solidFill>
                   <a:srgbClr val="000000"/>
                 </a:solidFill>
@@ -26539,7 +26539,7 @@
           </a:ln>
           <a:extLst>
             <a:ext uri="{91240B29-F687-4f45-9708-019B960494DF}">
-              <a14:hiddenLine xmlns:a14="http://schemas.microsoft.com/office/drawing/2010/main" xmlns="" w="12700" cap="sq">
+              <a14:hiddenLine xmlns="" xmlns:a14="http://schemas.microsoft.com/office/drawing/2010/main" w="12700" cap="sq">
                 <a:solidFill>
                   <a:srgbClr val="000000"/>
                 </a:solidFill>
@@ -27129,14 +27129,14 @@
           <a:ln/>
           <a:extLst>
             <a:ext uri="{909E8E84-426E-40dd-AFC4-6F175D3DCCD1}">
-              <a14:hiddenFill xmlns:a14="http://schemas.microsoft.com/office/drawing/2010/main" xmlns="">
+              <a14:hiddenFill xmlns="" xmlns:a14="http://schemas.microsoft.com/office/drawing/2010/main">
                 <a:solidFill>
                   <a:srgbClr val="FFFFFF"/>
                 </a:solidFill>
               </a14:hiddenFill>
             </a:ext>
             <a:ext uri="{91240B29-F687-4f45-9708-019B960494DF}">
-              <a14:hiddenLine xmlns:a14="http://schemas.microsoft.com/office/drawing/2010/main" xmlns="" w="9525">
+              <a14:hiddenLine xmlns="" xmlns:a14="http://schemas.microsoft.com/office/drawing/2010/main" w="9525">
                 <a:solidFill>
                   <a:srgbClr val="000000"/>
                 </a:solidFill>
@@ -27289,14 +27289,14 @@
           </a:ln>
           <a:extLst>
             <a:ext uri="{909E8E84-426E-40dd-AFC4-6F175D3DCCD1}">
-              <a14:hiddenFill xmlns:a14="http://schemas.microsoft.com/office/drawing/2010/main" xmlns="">
+              <a14:hiddenFill xmlns="" xmlns:a14="http://schemas.microsoft.com/office/drawing/2010/main">
                 <a:solidFill>
                   <a:srgbClr val="FFFFFF"/>
                 </a:solidFill>
               </a14:hiddenFill>
             </a:ext>
             <a:ext uri="{91240B29-F687-4f45-9708-019B960494DF}">
-              <a14:hiddenLine xmlns:a14="http://schemas.microsoft.com/office/drawing/2010/main" xmlns="" w="9525">
+              <a14:hiddenLine xmlns="" xmlns:a14="http://schemas.microsoft.com/office/drawing/2010/main" w="9525">
                 <a:solidFill>
                   <a:srgbClr val="000000"/>
                 </a:solidFill>
@@ -27362,7 +27362,7 @@
           </a:ln>
           <a:extLst>
             <a:ext uri="{91240B29-F687-4f45-9708-019B960494DF}">
-              <a14:hiddenLine xmlns:a14="http://schemas.microsoft.com/office/drawing/2010/main" xmlns="" w="12700" cap="sq">
+              <a14:hiddenLine xmlns="" xmlns:a14="http://schemas.microsoft.com/office/drawing/2010/main" w="12700" cap="sq">
                 <a:solidFill>
                   <a:srgbClr val="000000"/>
                 </a:solidFill>
@@ -27568,14 +27568,14 @@
           </a:ln>
           <a:extLst>
             <a:ext uri="{909E8E84-426E-40dd-AFC4-6F175D3DCCD1}">
-              <a14:hiddenFill xmlns:a14="http://schemas.microsoft.com/office/drawing/2010/main" xmlns="">
+              <a14:hiddenFill xmlns="" xmlns:a14="http://schemas.microsoft.com/office/drawing/2010/main">
                 <a:solidFill>
                   <a:srgbClr val="FFFFFF"/>
                 </a:solidFill>
               </a14:hiddenFill>
             </a:ext>
             <a:ext uri="{91240B29-F687-4f45-9708-019B960494DF}">
-              <a14:hiddenLine xmlns:a14="http://schemas.microsoft.com/office/drawing/2010/main" xmlns="" w="9525">
+              <a14:hiddenLine xmlns="" xmlns:a14="http://schemas.microsoft.com/office/drawing/2010/main" w="9525">
                 <a:solidFill>
                   <a:srgbClr val="000000"/>
                 </a:solidFill>
@@ -28729,14 +28729,14 @@
           <a:ln/>
           <a:extLst>
             <a:ext uri="{909E8E84-426E-40dd-AFC4-6F175D3DCCD1}">
-              <a14:hiddenFill xmlns:a14="http://schemas.microsoft.com/office/drawing/2010/main" xmlns="">
+              <a14:hiddenFill xmlns="" xmlns:a14="http://schemas.microsoft.com/office/drawing/2010/main">
                 <a:solidFill>
                   <a:srgbClr val="FFFFFF"/>
                 </a:solidFill>
               </a14:hiddenFill>
             </a:ext>
             <a:ext uri="{91240B29-F687-4f45-9708-019B960494DF}">
-              <a14:hiddenLine xmlns:a14="http://schemas.microsoft.com/office/drawing/2010/main" xmlns="" w="9525">
+              <a14:hiddenLine xmlns="" xmlns:a14="http://schemas.microsoft.com/office/drawing/2010/main" w="9525">
                 <a:solidFill>
                   <a:srgbClr val="000000"/>
                 </a:solidFill>
@@ -28893,7 +28893,7 @@
           </a:ln>
           <a:extLst>
             <a:ext uri="{91240B29-F687-4f45-9708-019B960494DF}">
-              <a14:hiddenLine xmlns:a14="http://schemas.microsoft.com/office/drawing/2010/main" xmlns="" w="12700" cap="sq">
+              <a14:hiddenLine xmlns="" xmlns:a14="http://schemas.microsoft.com/office/drawing/2010/main" w="12700" cap="sq">
                 <a:solidFill>
                   <a:srgbClr val="000000"/>
                 </a:solidFill>
@@ -29099,14 +29099,14 @@
           </a:ln>
           <a:extLst>
             <a:ext uri="{909E8E84-426E-40dd-AFC4-6F175D3DCCD1}">
-              <a14:hiddenFill xmlns:a14="http://schemas.microsoft.com/office/drawing/2010/main" xmlns="">
+              <a14:hiddenFill xmlns="" xmlns:a14="http://schemas.microsoft.com/office/drawing/2010/main">
                 <a:solidFill>
                   <a:srgbClr val="FFFFFF"/>
                 </a:solidFill>
               </a14:hiddenFill>
             </a:ext>
             <a:ext uri="{91240B29-F687-4f45-9708-019B960494DF}">
-              <a14:hiddenLine xmlns:a14="http://schemas.microsoft.com/office/drawing/2010/main" xmlns="" w="9525">
+              <a14:hiddenLine xmlns="" xmlns:a14="http://schemas.microsoft.com/office/drawing/2010/main" w="9525">
                 <a:solidFill>
                   <a:srgbClr val="000000"/>
                 </a:solidFill>
@@ -29171,7 +29171,7 @@
           </a:ln>
           <a:extLst>
             <a:ext uri="{909E8E84-426E-40dd-AFC4-6F175D3DCCD1}">
-              <a14:hiddenFill xmlns:a14="http://schemas.microsoft.com/office/drawing/2010/main" xmlns="">
+              <a14:hiddenFill xmlns="" xmlns:a14="http://schemas.microsoft.com/office/drawing/2010/main">
                 <a:solidFill>
                   <a:srgbClr val="FFFFFF"/>
                 </a:solidFill>
@@ -29230,7 +29230,7 @@
           </a:ln>
           <a:extLst>
             <a:ext uri="{909E8E84-426E-40dd-AFC4-6F175D3DCCD1}">
-              <a14:hiddenFill xmlns:a14="http://schemas.microsoft.com/office/drawing/2010/main" xmlns="">
+              <a14:hiddenFill xmlns="" xmlns:a14="http://schemas.microsoft.com/office/drawing/2010/main">
                 <a:noFill/>
               </a14:hiddenFill>
             </a:ext>
@@ -29273,7 +29273,7 @@
           </a:ln>
           <a:extLst>
             <a:ext uri="{909E8E84-426E-40dd-AFC4-6F175D3DCCD1}">
-              <a14:hiddenFill xmlns:a14="http://schemas.microsoft.com/office/drawing/2010/main" xmlns="">
+              <a14:hiddenFill xmlns="" xmlns:a14="http://schemas.microsoft.com/office/drawing/2010/main">
                 <a:noFill/>
               </a14:hiddenFill>
             </a:ext>
@@ -29316,7 +29316,7 @@
           </a:ln>
           <a:extLst>
             <a:ext uri="{909E8E84-426E-40dd-AFC4-6F175D3DCCD1}">
-              <a14:hiddenFill xmlns:a14="http://schemas.microsoft.com/office/drawing/2010/main" xmlns="">
+              <a14:hiddenFill xmlns="" xmlns:a14="http://schemas.microsoft.com/office/drawing/2010/main">
                 <a:noFill/>
               </a14:hiddenFill>
             </a:ext>
@@ -29359,7 +29359,7 @@
           </a:ln>
           <a:extLst>
             <a:ext uri="{909E8E84-426E-40dd-AFC4-6F175D3DCCD1}">
-              <a14:hiddenFill xmlns:a14="http://schemas.microsoft.com/office/drawing/2010/main" xmlns="">
+              <a14:hiddenFill xmlns="" xmlns:a14="http://schemas.microsoft.com/office/drawing/2010/main">
                 <a:noFill/>
               </a14:hiddenFill>
             </a:ext>
@@ -29402,7 +29402,7 @@
           </a:ln>
           <a:extLst>
             <a:ext uri="{909E8E84-426E-40dd-AFC4-6F175D3DCCD1}">
-              <a14:hiddenFill xmlns:a14="http://schemas.microsoft.com/office/drawing/2010/main" xmlns="">
+              <a14:hiddenFill xmlns="" xmlns:a14="http://schemas.microsoft.com/office/drawing/2010/main">
                 <a:noFill/>
               </a14:hiddenFill>
             </a:ext>
@@ -29445,7 +29445,7 @@
           </a:ln>
           <a:extLst>
             <a:ext uri="{909E8E84-426E-40dd-AFC4-6F175D3DCCD1}">
-              <a14:hiddenFill xmlns:a14="http://schemas.microsoft.com/office/drawing/2010/main" xmlns="">
+              <a14:hiddenFill xmlns="" xmlns:a14="http://schemas.microsoft.com/office/drawing/2010/main">
                 <a:noFill/>
               </a14:hiddenFill>
             </a:ext>
@@ -29488,7 +29488,7 @@
           </a:ln>
           <a:extLst>
             <a:ext uri="{909E8E84-426E-40dd-AFC4-6F175D3DCCD1}">
-              <a14:hiddenFill xmlns:a14="http://schemas.microsoft.com/office/drawing/2010/main" xmlns="">
+              <a14:hiddenFill xmlns="" xmlns:a14="http://schemas.microsoft.com/office/drawing/2010/main">
                 <a:noFill/>
               </a14:hiddenFill>
             </a:ext>
@@ -29531,7 +29531,7 @@
           </a:ln>
           <a:extLst>
             <a:ext uri="{909E8E84-426E-40dd-AFC4-6F175D3DCCD1}">
-              <a14:hiddenFill xmlns:a14="http://schemas.microsoft.com/office/drawing/2010/main" xmlns="">
+              <a14:hiddenFill xmlns="" xmlns:a14="http://schemas.microsoft.com/office/drawing/2010/main">
                 <a:noFill/>
               </a14:hiddenFill>
             </a:ext>
@@ -29574,7 +29574,7 @@
           </a:ln>
           <a:extLst>
             <a:ext uri="{909E8E84-426E-40dd-AFC4-6F175D3DCCD1}">
-              <a14:hiddenFill xmlns:a14="http://schemas.microsoft.com/office/drawing/2010/main" xmlns="">
+              <a14:hiddenFill xmlns="" xmlns:a14="http://schemas.microsoft.com/office/drawing/2010/main">
                 <a:noFill/>
               </a14:hiddenFill>
             </a:ext>
@@ -29617,7 +29617,7 @@
           </a:ln>
           <a:extLst>
             <a:ext uri="{909E8E84-426E-40dd-AFC4-6F175D3DCCD1}">
-              <a14:hiddenFill xmlns:a14="http://schemas.microsoft.com/office/drawing/2010/main" xmlns="">
+              <a14:hiddenFill xmlns="" xmlns:a14="http://schemas.microsoft.com/office/drawing/2010/main">
                 <a:noFill/>
               </a14:hiddenFill>
             </a:ext>
@@ -29660,7 +29660,7 @@
           </a:ln>
           <a:extLst>
             <a:ext uri="{909E8E84-426E-40dd-AFC4-6F175D3DCCD1}">
-              <a14:hiddenFill xmlns:a14="http://schemas.microsoft.com/office/drawing/2010/main" xmlns="">
+              <a14:hiddenFill xmlns="" xmlns:a14="http://schemas.microsoft.com/office/drawing/2010/main">
                 <a:noFill/>
               </a14:hiddenFill>
             </a:ext>
@@ -29703,7 +29703,7 @@
           </a:ln>
           <a:extLst>
             <a:ext uri="{909E8E84-426E-40dd-AFC4-6F175D3DCCD1}">
-              <a14:hiddenFill xmlns:a14="http://schemas.microsoft.com/office/drawing/2010/main" xmlns="">
+              <a14:hiddenFill xmlns="" xmlns:a14="http://schemas.microsoft.com/office/drawing/2010/main">
                 <a:noFill/>
               </a14:hiddenFill>
             </a:ext>
@@ -31011,14 +31011,14 @@
           <a:ln/>
           <a:extLst>
             <a:ext uri="{909E8E84-426E-40dd-AFC4-6F175D3DCCD1}">
-              <a14:hiddenFill xmlns:a14="http://schemas.microsoft.com/office/drawing/2010/main" xmlns="">
+              <a14:hiddenFill xmlns="" xmlns:a14="http://schemas.microsoft.com/office/drawing/2010/main">
                 <a:solidFill>
                   <a:srgbClr val="FFFFFF"/>
                 </a:solidFill>
               </a14:hiddenFill>
             </a:ext>
             <a:ext uri="{91240B29-F687-4f45-9708-019B960494DF}">
-              <a14:hiddenLine xmlns:a14="http://schemas.microsoft.com/office/drawing/2010/main" xmlns="" w="9525">
+              <a14:hiddenLine xmlns="" xmlns:a14="http://schemas.microsoft.com/office/drawing/2010/main" w="9525">
                 <a:solidFill>
                   <a:srgbClr val="000000"/>
                 </a:solidFill>
@@ -31171,14 +31171,14 @@
           </a:ln>
           <a:extLst>
             <a:ext uri="{909E8E84-426E-40dd-AFC4-6F175D3DCCD1}">
-              <a14:hiddenFill xmlns:a14="http://schemas.microsoft.com/office/drawing/2010/main" xmlns="">
+              <a14:hiddenFill xmlns="" xmlns:a14="http://schemas.microsoft.com/office/drawing/2010/main">
                 <a:solidFill>
                   <a:srgbClr val="FFFFFF"/>
                 </a:solidFill>
               </a14:hiddenFill>
             </a:ext>
             <a:ext uri="{91240B29-F687-4f45-9708-019B960494DF}">
-              <a14:hiddenLine xmlns:a14="http://schemas.microsoft.com/office/drawing/2010/main" xmlns="" w="12700" cap="sq">
+              <a14:hiddenLine xmlns="" xmlns:a14="http://schemas.microsoft.com/office/drawing/2010/main" w="12700" cap="sq">
                 <a:solidFill>
                   <a:srgbClr val="000000"/>
                 </a:solidFill>
@@ -31343,7 +31343,7 @@
           </a:ln>
           <a:extLst>
             <a:ext uri="{91240B29-F687-4f45-9708-019B960494DF}">
-              <a14:hiddenLine xmlns:a14="http://schemas.microsoft.com/office/drawing/2010/main" xmlns="" w="12700" cap="sq">
+              <a14:hiddenLine xmlns="" xmlns:a14="http://schemas.microsoft.com/office/drawing/2010/main" w="12700" cap="sq">
                 <a:solidFill>
                   <a:srgbClr val="000000"/>
                 </a:solidFill>
@@ -31552,7 +31552,7 @@
           </a:ln>
           <a:extLst>
             <a:ext uri="{909E8E84-426E-40dd-AFC4-6F175D3DCCD1}">
-              <a14:hiddenFill xmlns:a14="http://schemas.microsoft.com/office/drawing/2010/main" xmlns="">
+              <a14:hiddenFill xmlns="" xmlns:a14="http://schemas.microsoft.com/office/drawing/2010/main">
                 <a:solidFill>
                   <a:srgbClr val="FFFFFF"/>
                 </a:solidFill>
@@ -31877,14 +31877,14 @@
           <a:ln/>
           <a:extLst>
             <a:ext uri="{909E8E84-426E-40dd-AFC4-6F175D3DCCD1}">
-              <a14:hiddenFill xmlns:a14="http://schemas.microsoft.com/office/drawing/2010/main" xmlns="">
+              <a14:hiddenFill xmlns="" xmlns:a14="http://schemas.microsoft.com/office/drawing/2010/main">
                 <a:solidFill>
                   <a:srgbClr val="FFFFFF"/>
                 </a:solidFill>
               </a14:hiddenFill>
             </a:ext>
             <a:ext uri="{91240B29-F687-4f45-9708-019B960494DF}">
-              <a14:hiddenLine xmlns:a14="http://schemas.microsoft.com/office/drawing/2010/main" xmlns="" w="9525">
+              <a14:hiddenLine xmlns="" xmlns:a14="http://schemas.microsoft.com/office/drawing/2010/main" w="9525">
                 <a:solidFill>
                   <a:srgbClr val="000000"/>
                 </a:solidFill>
@@ -32037,14 +32037,14 @@
           </a:ln>
           <a:extLst>
             <a:ext uri="{909E8E84-426E-40dd-AFC4-6F175D3DCCD1}">
-              <a14:hiddenFill xmlns:a14="http://schemas.microsoft.com/office/drawing/2010/main" xmlns="">
+              <a14:hiddenFill xmlns="" xmlns:a14="http://schemas.microsoft.com/office/drawing/2010/main">
                 <a:solidFill>
                   <a:srgbClr val="FFFFFF"/>
                 </a:solidFill>
               </a14:hiddenFill>
             </a:ext>
             <a:ext uri="{91240B29-F687-4f45-9708-019B960494DF}">
-              <a14:hiddenLine xmlns:a14="http://schemas.microsoft.com/office/drawing/2010/main" xmlns="" w="12700" cap="sq">
+              <a14:hiddenLine xmlns="" xmlns:a14="http://schemas.microsoft.com/office/drawing/2010/main" w="12700" cap="sq">
                 <a:solidFill>
                   <a:srgbClr val="000000"/>
                 </a:solidFill>
@@ -32217,7 +32217,7 @@
           </a:ln>
           <a:extLst>
             <a:ext uri="{91240B29-F687-4f45-9708-019B960494DF}">
-              <a14:hiddenLine xmlns:a14="http://schemas.microsoft.com/office/drawing/2010/main" xmlns="" w="12700" cap="sq">
+              <a14:hiddenLine xmlns="" xmlns:a14="http://schemas.microsoft.com/office/drawing/2010/main" w="12700" cap="sq">
                 <a:solidFill>
                   <a:srgbClr val="000000"/>
                 </a:solidFill>
@@ -32507,14 +32507,14 @@
           </a:ln>
           <a:extLst>
             <a:ext uri="{909E8E84-426E-40dd-AFC4-6F175D3DCCD1}">
-              <a14:hiddenFill xmlns:a14="http://schemas.microsoft.com/office/drawing/2010/main" xmlns="">
+              <a14:hiddenFill xmlns="" xmlns:a14="http://schemas.microsoft.com/office/drawing/2010/main">
                 <a:solidFill>
                   <a:srgbClr val="FFFFFF"/>
                 </a:solidFill>
               </a14:hiddenFill>
             </a:ext>
             <a:ext uri="{91240B29-F687-4f45-9708-019B960494DF}">
-              <a14:hiddenLine xmlns:a14="http://schemas.microsoft.com/office/drawing/2010/main" xmlns="" w="12700" cap="sq">
+              <a14:hiddenLine xmlns="" xmlns:a14="http://schemas.microsoft.com/office/drawing/2010/main" w="12700" cap="sq">
                 <a:solidFill>
                   <a:srgbClr val="000000"/>
                 </a:solidFill>
@@ -32671,7 +32671,7 @@
           </a:ln>
           <a:extLst>
             <a:ext uri="{91240B29-F687-4f45-9708-019B960494DF}">
-              <a14:hiddenLine xmlns:a14="http://schemas.microsoft.com/office/drawing/2010/main" xmlns="" w="12700" cap="sq">
+              <a14:hiddenLine xmlns="" xmlns:a14="http://schemas.microsoft.com/office/drawing/2010/main" w="12700" cap="sq">
                 <a:solidFill>
                   <a:srgbClr val="000000"/>
                 </a:solidFill>
@@ -33197,14 +33197,14 @@
           <a:ln/>
           <a:extLst>
             <a:ext uri="{909E8E84-426E-40dd-AFC4-6F175D3DCCD1}">
-              <a14:hiddenFill xmlns:a14="http://schemas.microsoft.com/office/drawing/2010/main" xmlns="">
+              <a14:hiddenFill xmlns="" xmlns:a14="http://schemas.microsoft.com/office/drawing/2010/main">
                 <a:solidFill>
                   <a:srgbClr val="FFFFFF"/>
                 </a:solidFill>
               </a14:hiddenFill>
             </a:ext>
             <a:ext uri="{91240B29-F687-4f45-9708-019B960494DF}">
-              <a14:hiddenLine xmlns:a14="http://schemas.microsoft.com/office/drawing/2010/main" xmlns="" w="9525">
+              <a14:hiddenLine xmlns="" xmlns:a14="http://schemas.microsoft.com/office/drawing/2010/main" w="9525">
                 <a:solidFill>
                   <a:srgbClr val="000000"/>
                 </a:solidFill>
@@ -33357,14 +33357,14 @@
           </a:ln>
           <a:extLst>
             <a:ext uri="{909E8E84-426E-40dd-AFC4-6F175D3DCCD1}">
-              <a14:hiddenFill xmlns:a14="http://schemas.microsoft.com/office/drawing/2010/main" xmlns="">
+              <a14:hiddenFill xmlns="" xmlns:a14="http://schemas.microsoft.com/office/drawing/2010/main">
                 <a:solidFill>
                   <a:srgbClr val="FFFFFF"/>
                 </a:solidFill>
               </a14:hiddenFill>
             </a:ext>
             <a:ext uri="{91240B29-F687-4f45-9708-019B960494DF}">
-              <a14:hiddenLine xmlns:a14="http://schemas.microsoft.com/office/drawing/2010/main" xmlns="" w="12700" cap="sq">
+              <a14:hiddenLine xmlns="" xmlns:a14="http://schemas.microsoft.com/office/drawing/2010/main" w="12700" cap="sq">
                 <a:solidFill>
                   <a:srgbClr val="000000"/>
                 </a:solidFill>
@@ -33529,7 +33529,7 @@
           </a:ln>
           <a:extLst>
             <a:ext uri="{91240B29-F687-4f45-9708-019B960494DF}">
-              <a14:hiddenLine xmlns:a14="http://schemas.microsoft.com/office/drawing/2010/main" xmlns="" w="12700" cap="sq">
+              <a14:hiddenLine xmlns="" xmlns:a14="http://schemas.microsoft.com/office/drawing/2010/main" w="12700" cap="sq">
                 <a:solidFill>
                   <a:srgbClr val="000000"/>
                 </a:solidFill>
@@ -33716,7 +33716,7 @@
           </a:ln>
           <a:extLst>
             <a:ext uri="{909E8E84-426E-40dd-AFC4-6F175D3DCCD1}">
-              <a14:hiddenFill xmlns:a14="http://schemas.microsoft.com/office/drawing/2010/main" xmlns="">
+              <a14:hiddenFill xmlns="" xmlns:a14="http://schemas.microsoft.com/office/drawing/2010/main">
                 <a:solidFill>
                   <a:srgbClr val="FFFFFF"/>
                 </a:solidFill>

</xml_diff>